<commit_message>
Day 86: README polish, live link, v0.3 release
</commit_message>
<xml_diff>
--- a/docs/presentation.pptx
+++ b/docs/presentation.pptx
@@ -4,6 +4,9 @@
   <p:sldMasterIdLst>
     <p:sldMasterId id="2147483648" r:id="rId1"/>
   </p:sldMasterIdLst>
+  <p:notesMasterIdLst>
+    <p:notesMasterId r:id="rId14"/>
+  </p:notesMasterIdLst>
   <p:sldIdLst>
     <p:sldId id="256" r:id="rId2"/>
     <p:sldId id="257" r:id="rId3"/>
@@ -18,10 +21,7 @@
     <p:sldId id="266" r:id="rId12"/>
     <p:sldId id="267" r:id="rId13"/>
   </p:sldIdLst>
-  <p:notesMasterIdLst>
-    <p:notesMasterId r:id="rId14"/>
-  </p:notesMasterIdLst>
-  <p:sldSz cx="9144000" cy="5143500"/>
+  <p:sldSz cx="9144000" cy="5143500" type="screen16x9"/>
   <p:notesSz cx="5143500" cy="9144000"/>
   <p:defaultTextStyle>
     <a:lvl1pPr marL="0" algn="l" defTabSz="914400" rtl="0" eaLnBrk="1" latinLnBrk="0" hangingPunct="1">
@@ -115,6 +115,11 @@
       </a:defRPr>
     </a:lvl9pPr>
   </p:defaultTextStyle>
+  <p:extLst>
+    <p:ext uri="{EFAFB233-063F-42B5-8137-9DF3F51BA10A}">
+      <p15:sldGuideLst xmlns:p15="http://schemas.microsoft.com/office/powerpoint/2012/main"/>
+    </p:ext>
+  </p:extLst>
 </p:presentation>
 </file>
 
@@ -140,234 +145,10 @@
           <a:chExt cx="0" cy="0"/>
         </a:xfrm>
       </p:grpSpPr>
-      <p:sp>
-        <p:nvSpPr>
-          <p:cNvPr id="2" name="Header Placeholder 1"/>
-          <p:cNvSpPr>
-            <a:spLocks noGrp="1"/>
-          </p:cNvSpPr>
-          <p:nvPr>
-            <p:ph type="hdr" sz="quarter"/>
-          </p:nvPr>
-        </p:nvSpPr>
-        <p:spPr>
-          <a:xfrm>
-            <a:off x="0" y="0"/>
-            <a:ext cx="2971800" cy="458788"/>
-          </a:xfrm>
-          <a:prstGeom prst="rect">
-            <a:avLst/>
-          </a:prstGeom>
-        </p:spPr>
-        <p:txBody>
-          <a:bodyPr vert="horz" lIns="91440" tIns="45720" rIns="91440" bIns="45720" rtlCol="0"/>
-          <a:lstStyle>
-            <a:lvl1pPr algn="l">
-              <a:defRPr sz="1200"/>
-            </a:lvl1pPr>
-          </a:lstStyle>
-          <a:p>
-            <a:endParaRPr lang="en-US"/>
-          </a:p>
-        </p:txBody>
-      </p:sp>
-      <p:sp>
-        <p:nvSpPr>
-          <p:cNvPr id="3" name="Date Placeholder 2"/>
-          <p:cNvSpPr>
-            <a:spLocks noGrp="1"/>
-          </p:cNvSpPr>
-          <p:nvPr>
-            <p:ph type="dt" idx="1"/>
-          </p:nvPr>
-        </p:nvSpPr>
-        <p:spPr>
-          <a:xfrm>
-            <a:off x="3884613" y="0"/>
-            <a:ext cx="2971800" cy="458788"/>
-          </a:xfrm>
-          <a:prstGeom prst="rect">
-            <a:avLst/>
-          </a:prstGeom>
-        </p:spPr>
-        <p:txBody>
-          <a:bodyPr vert="horz" lIns="91440" tIns="45720" rIns="91440" bIns="45720" rtlCol="0"/>
-          <a:lstStyle>
-            <a:lvl1pPr algn="r">
-              <a:defRPr sz="1200"/>
-            </a:lvl1pPr>
-          </a:lstStyle>
-          <a:p>
-            <a:fld id="{5282F153-3F37-0F45-9E97-73ACFA13230C}" type="datetimeFigureOut">
-              <a:rPr lang="en-US"/>
-              <a:t>7/23/19</a:t>
-            </a:fld>
-            <a:endParaRPr lang="en-US"/>
-          </a:p>
-        </p:txBody>
-      </p:sp>
-      <p:sp>
-        <p:nvSpPr>
-          <p:cNvPr id="4" name="Slide Image Placeholder 3"/>
-          <p:cNvSpPr>
-            <a:spLocks noGrp="1" noRot="1" noChangeAspect="1"/>
-          </p:cNvSpPr>
-          <p:nvPr>
-            <p:ph type="sldImg" idx="2"/>
-          </p:nvPr>
-        </p:nvSpPr>
-        <p:spPr>
-          <a:xfrm>
-            <a:off x="685800" y="1143000"/>
-            <a:ext cx="5486400" cy="3086100"/>
-          </a:xfrm>
-          <a:prstGeom prst="rect">
-            <a:avLst/>
-          </a:prstGeom>
-          <a:noFill/>
-          <a:ln w="12700">
-            <a:solidFill>
-              <a:prstClr val="black"/>
-            </a:solidFill>
-          </a:ln>
-        </p:spPr>
-        <p:txBody>
-          <a:bodyPr vert="horz" lIns="91440" tIns="45720" rIns="91440" bIns="45720" rtlCol="0" anchor="ctr"/>
-          <a:lstStyle/>
-          <a:p>
-            <a:endParaRPr lang="en-US"/>
-          </a:p>
-        </p:txBody>
-      </p:sp>
-      <p:sp>
-        <p:nvSpPr>
-          <p:cNvPr id="5" name="Notes Placeholder 4"/>
-          <p:cNvSpPr>
-            <a:spLocks noGrp="1"/>
-          </p:cNvSpPr>
-          <p:nvPr>
-            <p:ph type="body" sz="quarter" idx="3"/>
-          </p:nvPr>
-        </p:nvSpPr>
-        <p:spPr>
-          <a:xfrm>
-            <a:off x="685800" y="4400550"/>
-            <a:ext cx="5486400" cy="3600450"/>
-          </a:xfrm>
-          <a:prstGeom prst="rect">
-            <a:avLst/>
-          </a:prstGeom>
-        </p:spPr>
-        <p:txBody>
-          <a:bodyPr vert="horz" lIns="91440" tIns="45720" rIns="91440" bIns="45720" rtlCol="0"/>
-          <a:lstStyle/>
-          <a:p>
-            <a:pPr lvl="0"/>
-            <a:r>
-              <a:rPr lang="en-US"/>
-              <a:t>Click to edit Master text styles</a:t>
-            </a:r>
-          </a:p>
-          <a:p>
-            <a:pPr lvl="1"/>
-            <a:r>
-              <a:rPr lang="en-US"/>
-              <a:t>Second level</a:t>
-            </a:r>
-          </a:p>
-          <a:p>
-            <a:pPr lvl="2"/>
-            <a:r>
-              <a:rPr lang="en-US"/>
-              <a:t>Third level</a:t>
-            </a:r>
-          </a:p>
-          <a:p>
-            <a:pPr lvl="3"/>
-            <a:r>
-              <a:rPr lang="en-US"/>
-              <a:t>Fourth level</a:t>
-            </a:r>
-          </a:p>
-          <a:p>
-            <a:pPr lvl="4"/>
-            <a:r>
-              <a:rPr lang="en-US"/>
-              <a:t>Fifth level</a:t>
-            </a:r>
-          </a:p>
-        </p:txBody>
-      </p:sp>
-      <p:sp>
-        <p:nvSpPr>
-          <p:cNvPr id="6" name="Footer Placeholder 5"/>
-          <p:cNvSpPr>
-            <a:spLocks noGrp="1"/>
-          </p:cNvSpPr>
-          <p:nvPr>
-            <p:ph type="ftr" sz="quarter" idx="4"/>
-          </p:nvPr>
-        </p:nvSpPr>
-        <p:spPr>
-          <a:xfrm>
-            <a:off x="0" y="8685213"/>
-            <a:ext cx="2971800" cy="458787"/>
-          </a:xfrm>
-          <a:prstGeom prst="rect">
-            <a:avLst/>
-          </a:prstGeom>
-        </p:spPr>
-        <p:txBody>
-          <a:bodyPr vert="horz" lIns="91440" tIns="45720" rIns="91440" bIns="45720" rtlCol="0" anchor="b"/>
-          <a:lstStyle>
-            <a:lvl1pPr algn="l">
-              <a:defRPr sz="1200"/>
-            </a:lvl1pPr>
-          </a:lstStyle>
-          <a:p>
-            <a:endParaRPr lang="en-US"/>
-          </a:p>
-        </p:txBody>
-      </p:sp>
-      <p:sp>
-        <p:nvSpPr>
-          <p:cNvPr id="7" name="Slide Number Placeholder 6"/>
-          <p:cNvSpPr>
-            <a:spLocks noGrp="1"/>
-          </p:cNvSpPr>
-          <p:nvPr>
-            <p:ph type="sldNum" sz="quarter" idx="5"/>
-          </p:nvPr>
-        </p:nvSpPr>
-        <p:spPr>
-          <a:xfrm>
-            <a:off x="3884613" y="8685213"/>
-            <a:ext cx="2971800" cy="458787"/>
-          </a:xfrm>
-          <a:prstGeom prst="rect">
-            <a:avLst/>
-          </a:prstGeom>
-        </p:spPr>
-        <p:txBody>
-          <a:bodyPr vert="horz" lIns="91440" tIns="45720" rIns="91440" bIns="45720" rtlCol="0" anchor="b"/>
-          <a:lstStyle>
-            <a:lvl1pPr algn="r">
-              <a:defRPr sz="1200"/>
-            </a:lvl1pPr>
-          </a:lstStyle>
-          <a:p>
-            <a:fld id="{CE5E9CC1-C706-0F49-92D6-E571CC5EEA8F}" type="slidenum">
-              <a:rPr lang="en-US"/>
-              <a:t>‹#›</a:t>
-            </a:fld>
-            <a:endParaRPr lang="en-US"/>
-          </a:p>
-        </p:txBody>
-      </p:sp>
     </p:spTree>
     <p:extLst>
       <p:ext uri="{BB962C8B-B14F-4D97-AF65-F5344CB8AC3E}">
-        <p14:creationId xmlns:p14="http://schemas.microsoft.com/office/powerpoint/2010/main" val="1024086991"/>
+        <p14:creationId xmlns:p14="http://schemas.microsoft.com/office/powerpoint/2010/main" val="746296652"/>
       </p:ext>
     </p:extLst>
   </p:cSld>
@@ -515,7 +296,6 @@
               <a:rPr lang="en-US" dirty="0"/>
               <a:t>Good morning everyone. We are Rashi Sharma, Sabila Nigar and Preeti Kumari. Our project is the AI Fashion Color Fit Matcher and Virtual Stylist. In simple words: you give it a photo, and it tells you which colors and outfits suit your skin tone. The three dots stand for warm, neutral and cool skin tones.</a:t>
             </a:r>
-            <a:endParaRPr lang="en-US" dirty="0"/>
           </a:p>
         </p:txBody>
       </p:sp>
@@ -601,9 +381,24 @@
           <a:p>
             <a:r>
               <a:rPr lang="en-US" dirty="0"/>
-              <a:t>Testing has three levels. Ten automated pytest tests check skin tone classes, the error dictionary, the scoring formula, color math and harmony labels. A manual full-flow test covers one complete user journey. Quality checks include a UI audit of 13 screens, mobile checks and a custom code audit tool. Testing found one real bug: the compatibility check tested for None but the function returned an error dictionary. We fixed it.</a:t>
-            </a:r>
-            <a:endParaRPr lang="en-US" dirty="0"/>
+              <a:t>Testing has three levels. </a:t>
+            </a:r>
+            <a:r>
+              <a:rPr lang="en-IN" dirty="0"/>
+              <a:t>Twelve automated </a:t>
+            </a:r>
+            <a:r>
+              <a:rPr lang="en-IN" dirty="0" err="1"/>
+              <a:t>pytest</a:t>
+            </a:r>
+            <a:r>
+              <a:rPr lang="en-IN" dirty="0"/>
+              <a:t> tests </a:t>
+            </a:r>
+            <a:r>
+              <a:rPr lang="en-US" dirty="0"/>
+              <a:t>check skin tone classes, the error dictionary, the scoring formula, color math and harmony labels. A manual full-flow test covers one complete user journey. Quality checks include a UI audit of 13 screens, mobile checks and a custom code audit tool. Testing found one real bug: the compatibility check tested for None but the function returned an error dictionary. We fixed it.</a:t>
+            </a:r>
           </a:p>
         </p:txBody>
       </p:sp>
@@ -691,7 +486,6 @@
               <a:rPr lang="en-US" dirty="0"/>
               <a:t>Being honest about limits: skin tone detection depends on lighting and uses fixed thresholds. The outfit database is 150 synthetic outfits, not real products. Accuracy has not been benchmarked on labeled photos. The try-on is a flat color tint. For the future: a better model with fairness checks, MediaPipe pose for body shape, clothing segmentation, live video, a real product catalog, and user accounts with a database.</a:t>
             </a:r>
-            <a:endParaRPr lang="en-US" dirty="0"/>
           </a:p>
         </p:txBody>
       </p:sp>
@@ -779,7 +573,6 @@
               <a:rPr lang="en-US" dirty="0"/>
               <a:t>Now we will show the app live. Follow this order: take the style quiz, analyze my look, view recommendations, try on a color, ask the stylist a question, then open the dashboard. Conclusion: a useful stylist can be built from face detection, color-space analysis, clustering, transparent rules and a language model with clear boundaries. Thank you. We are happy to take questions.</a:t>
             </a:r>
-            <a:endParaRPr lang="en-US" dirty="0"/>
           </a:p>
         </p:txBody>
       </p:sp>
@@ -867,7 +660,6 @@
               <a:rPr lang="en-US" dirty="0"/>
               <a:t>Most people choose clothes by guesswork, and professional stylists are expensive. Our app automates this advice. From one photo it finds the face, classifies skin tone, recommends colors and outfits, and lets the user chat with an AI stylist. Every recommendation can be explained in plain English.</a:t>
             </a:r>
-            <a:endParaRPr lang="en-US" dirty="0"/>
           </a:p>
         </p:txBody>
       </p:sp>
@@ -955,7 +747,6 @@
               <a:rPr lang="en-US" dirty="0"/>
               <a:t>These are the goals we set. Detect the face and skin tone, recommend colors and outfits, let users preview a color on their own photo, add a fashion-only chatbot, personalize with occasion, season, body shape and a style quiz, and deliver it as a polished, tested web app. It is a styling aid, not a medical tool.</a:t>
             </a:r>
-            <a:endParaRPr lang="en-US" dirty="0"/>
           </a:p>
         </p:txBody>
       </p:sp>
@@ -1043,7 +834,6 @@
               <a:rPr lang="en-US" dirty="0"/>
               <a:t>The app has three layers. The user interface is 13 Streamlit pages. The logic layer is small Python modules in the src folder, one job each. The data layer is JSON and CSV files. The only outside service is the Groq API for the chatbot. Pages hold no heavy logic, and every function returns an error dictionary so the app never crashes on bad input.</a:t>
             </a:r>
-            <a:endParaRPr lang="en-US" dirty="0"/>
           </a:p>
         </p:txBody>
       </p:sp>
@@ -1131,7 +921,6 @@
               <a:rPr lang="en-US" dirty="0"/>
               <a:t>This is the main pipeline. First the photo is validated. Then a Haar cascade finds the face. We average the HSV values of the face region, apply simple rules to get warm, neutral or cool, and from that we get recommended colors. The same skin tone feeds the outfit scorer and the AI stylist context.</a:t>
             </a:r>
-            <a:endParaRPr lang="en-US" dirty="0"/>
           </a:p>
         </p:txBody>
       </p:sp>
@@ -1219,7 +1008,6 @@
               <a:rPr lang="en-US" dirty="0"/>
               <a:t>Skin tone uses simple, explainable rules. The face pixels are converted from BGR to HSV and averaged. If hue is 20 or less and saturation is above 60, it is warm. Hue 20 or less with saturation 60 or below is neutral. Higher hue is cool. We used HSV because it separates color from brightness, so lighting matters less than with raw RGB. The trade-off is lower robustness, which we list under limitations.</a:t>
             </a:r>
-            <a:endParaRPr lang="en-US" dirty="0"/>
           </a:p>
         </p:txBody>
       </p:sp>
@@ -1307,7 +1095,6 @@
               <a:rPr lang="en-US" dirty="0"/>
               <a:t>The recommender picks outfits from a 150-outfit database. It first tries an exact match on color, occasion and season, then relaxes the season, then matches on color alone. The final score is 40 percent skin match, 30 percent color harmony, 30 percent occasion fit. Dominant clothing colors come from K-Means clustering with k equal to 5. Because every number comes from a visible rule, the Why this outfit explanation is exact.</a:t>
             </a:r>
-            <a:endParaRPr lang="en-US" dirty="0"/>
           </a:p>
         </p:txBody>
       </p:sp>
@@ -1395,7 +1182,6 @@
               <a:rPr lang="en-US" dirty="0"/>
               <a:t>Beyond the core analysis, the app has a virtual try-on that blends a color over the estimated torso, a Groq-powered chatbot that knows your analysis, a style quiz with three personas, a Mirror Mode page for a smart-mirror feel, a dashboard of usage analytics, and a downloadable HTML style report.</a:t>
             </a:r>
-            <a:endParaRPr lang="en-US" dirty="0"/>
           </a:p>
         </p:txBody>
       </p:sp>
@@ -1483,7 +1269,6 @@
               <a:rPr lang="en-US" dirty="0"/>
               <a:t>Everything is Python. Streamlit gives a full web app without a separate front end. OpenCV runs on a normal CPU and its Haar detector needs no training. Scikit-learn gives reliable K-Means. Groq gives fast chatbot replies with a free tier. Pytest runs our tests with one command.</a:t>
             </a:r>
-            <a:endParaRPr lang="en-US" dirty="0"/>
           </a:p>
         </p:txBody>
       </p:sp>
@@ -1556,6 +1341,11 @@
 <file path=ppt/slideMasters/slideMaster1.xml><?xml version="1.0" encoding="utf-8"?>
 <p:sldMaster xmlns:a="http://schemas.openxmlformats.org/drawingml/2006/main" xmlns:r="http://schemas.openxmlformats.org/officeDocument/2006/relationships" xmlns:p="http://schemas.openxmlformats.org/presentationml/2006/main">
   <p:cSld>
+    <p:bg>
+      <p:bgRef idx="1001">
+        <a:schemeClr val="bg1"/>
+      </p:bgRef>
+    </p:bg>
     <p:spTree>
       <p:nvGrpSpPr>
         <p:cNvPr id="1" name=""/>
@@ -1838,6 +1628,7 @@
         <a:solidFill>
           <a:srgbClr val="0E1117"/>
         </a:solidFill>
+        <a:effectLst/>
       </p:bgPr>
     </p:bg>
     <p:spTree>
@@ -1875,7 +1666,7 @@
           <a:bodyPr wrap="square" lIns="0" tIns="0" rIns="0" bIns="0" rtlCol="0" anchor="ctr"/>
           <a:lstStyle/>
           <a:p>
-            <a:pPr indent="0" marL="0">
+            <a:pPr marL="0" indent="0">
               <a:buNone/>
             </a:pPr>
             <a:r>
@@ -1914,7 +1705,7 @@
           <a:bodyPr wrap="square" lIns="0" tIns="0" rIns="0" bIns="0" rtlCol="0" anchor="ctr"/>
           <a:lstStyle/>
           <a:p>
-            <a:pPr indent="0" marL="0">
+            <a:pPr marL="0" indent="0">
               <a:buNone/>
             </a:pPr>
             <a:r>
@@ -1931,7 +1722,7 @@
       </p:sp>
       <p:graphicFrame>
         <p:nvGraphicFramePr>
-          <p:cNvPr id="2" name="Table 0"/>
+          <p:cNvPr id="4" name="Table 0"/>
           <p:cNvGraphicFramePr>
             <a:graphicFrameLocks noGrp="1"/>
           </p:cNvGraphicFramePr>
@@ -1945,15 +1736,27 @@
         </p:nvGraphicFramePr>
         <p:xfrm>
           <a:off x="2743200" y="3291840"/>
-          <a:ext cx="5852160" cy="914400"/>
+          <a:ext cx="5852160" cy="1219200"/>
         </p:xfrm>
         <a:graphic>
           <a:graphicData uri="http://schemas.openxmlformats.org/drawingml/2006/table">
             <a:tbl>
               <a:tblPr/>
               <a:tblGrid>
-                <a:gridCol w="2926080"/>
-                <a:gridCol w="2926080"/>
+                <a:gridCol w="2926080">
+                  <a:extLst>
+                    <a:ext uri="{9D8B030D-6E8A-4147-A177-3AD203B41FA5}">
+                      <a16:colId xmlns:a16="http://schemas.microsoft.com/office/drawing/2014/main" val="20000"/>
+                    </a:ext>
+                  </a:extLst>
+                </a:gridCol>
+                <a:gridCol w="2926080">
+                  <a:extLst>
+                    <a:ext uri="{9D8B030D-6E8A-4147-A177-3AD203B41FA5}">
+                      <a16:colId xmlns:a16="http://schemas.microsoft.com/office/drawing/2014/main" val="20001"/>
+                    </a:ext>
+                  </a:extLst>
+                </a:gridCol>
               </a:tblGrid>
               <a:tr h="301752">
                 <a:tc>
@@ -1961,7 +1764,7 @@
                     <a:bodyPr/>
                     <a:lstStyle/>
                     <a:p>
-                      <a:pPr indent="0" marL="0">
+                      <a:pPr marL="0" indent="0">
                         <a:buNone/>
                       </a:pPr>
                       <a:r>
@@ -1982,7 +1785,7 @@
                       </a:endParaRPr>
                     </a:p>
                   </a:txBody>
-                  <a:tcPr marL="91440" marR="91440" marT="45720" marB="45720" anchor="ctr">
+                  <a:tcPr anchor="ctr">
                     <a:lnL w="12700" cap="flat" cmpd="sng" algn="ctr">
                       <a:solidFill>
                         <a:srgbClr val="0E1117"/>
@@ -2029,7 +1832,7 @@
                     <a:bodyPr/>
                     <a:lstStyle/>
                     <a:p>
-                      <a:pPr indent="0" marL="0">
+                      <a:pPr marL="0" indent="0">
                         <a:buNone/>
                       </a:pPr>
                       <a:r>
@@ -2050,7 +1853,7 @@
                       </a:endParaRPr>
                     </a:p>
                   </a:txBody>
-                  <a:tcPr marL="91440" marR="91440" marT="45720" marB="45720" anchor="ctr">
+                  <a:tcPr anchor="ctr">
                     <a:lnL w="12700" cap="flat" cmpd="sng" algn="ctr">
                       <a:solidFill>
                         <a:srgbClr val="0E1117"/>
@@ -2092,6 +1895,11 @@
                     </a:solidFill>
                   </a:tcPr>
                 </a:tc>
+                <a:extLst>
+                  <a:ext uri="{0D108BD9-81ED-4DB2-BD59-A6C34878D82A}">
+                    <a16:rowId xmlns:a16="http://schemas.microsoft.com/office/drawing/2014/main" val="10000"/>
+                  </a:ext>
+                </a:extLst>
               </a:tr>
               <a:tr h="301752">
                 <a:tc>
@@ -2099,7 +1907,7 @@
                     <a:bodyPr/>
                     <a:lstStyle/>
                     <a:p>
-                      <a:pPr indent="0" marL="0">
+                      <a:pPr marL="0" indent="0">
                         <a:buNone/>
                       </a:pPr>
                       <a:r>
@@ -2120,7 +1928,7 @@
                       </a:endParaRPr>
                     </a:p>
                   </a:txBody>
-                  <a:tcPr marL="91440" marR="91440" marT="45720" marB="45720" anchor="ctr">
+                  <a:tcPr anchor="ctr">
                     <a:lnL w="12700" cap="flat" cmpd="sng" algn="ctr">
                       <a:solidFill>
                         <a:srgbClr val="0E1117"/>
@@ -2167,7 +1975,7 @@
                     <a:bodyPr/>
                     <a:lstStyle/>
                     <a:p>
-                      <a:pPr indent="0" marL="0">
+                      <a:pPr marL="0" indent="0">
                         <a:buNone/>
                       </a:pPr>
                       <a:r>
@@ -2188,7 +1996,7 @@
                       </a:endParaRPr>
                     </a:p>
                   </a:txBody>
-                  <a:tcPr marL="91440" marR="91440" marT="45720" marB="45720" anchor="ctr">
+                  <a:tcPr anchor="ctr">
                     <a:lnL w="12700" cap="flat" cmpd="sng" algn="ctr">
                       <a:solidFill>
                         <a:srgbClr val="0E1117"/>
@@ -2230,6 +2038,11 @@
                     </a:solidFill>
                   </a:tcPr>
                 </a:tc>
+                <a:extLst>
+                  <a:ext uri="{0D108BD9-81ED-4DB2-BD59-A6C34878D82A}">
+                    <a16:rowId xmlns:a16="http://schemas.microsoft.com/office/drawing/2014/main" val="10001"/>
+                  </a:ext>
+                </a:extLst>
               </a:tr>
               <a:tr h="301752">
                 <a:tc>
@@ -2237,7 +2050,7 @@
                     <a:bodyPr/>
                     <a:lstStyle/>
                     <a:p>
-                      <a:pPr indent="0" marL="0">
+                      <a:pPr marL="0" indent="0">
                         <a:buNone/>
                       </a:pPr>
                       <a:r>
@@ -2258,7 +2071,7 @@
                       </a:endParaRPr>
                     </a:p>
                   </a:txBody>
-                  <a:tcPr marL="91440" marR="91440" marT="45720" marB="45720" anchor="ctr">
+                  <a:tcPr anchor="ctr">
                     <a:lnL w="12700" cap="flat" cmpd="sng" algn="ctr">
                       <a:solidFill>
                         <a:srgbClr val="0E1117"/>
@@ -2305,7 +2118,7 @@
                     <a:bodyPr/>
                     <a:lstStyle/>
                     <a:p>
-                      <a:pPr indent="0" marL="0">
+                      <a:pPr marL="0" indent="0">
                         <a:buNone/>
                       </a:pPr>
                       <a:r>
@@ -2326,7 +2139,7 @@
                       </a:endParaRPr>
                     </a:p>
                   </a:txBody>
-                  <a:tcPr marL="91440" marR="91440" marT="45720" marB="45720" anchor="ctr">
+                  <a:tcPr anchor="ctr">
                     <a:lnL w="12700" cap="flat" cmpd="sng" algn="ctr">
                       <a:solidFill>
                         <a:srgbClr val="0E1117"/>
@@ -2368,6 +2181,11 @@
                     </a:solidFill>
                   </a:tcPr>
                 </a:tc>
+                <a:extLst>
+                  <a:ext uri="{0D108BD9-81ED-4DB2-BD59-A6C34878D82A}">
+                    <a16:rowId xmlns:a16="http://schemas.microsoft.com/office/drawing/2014/main" val="10002"/>
+                  </a:ext>
+                </a:extLst>
               </a:tr>
               <a:tr h="301752">
                 <a:tc>
@@ -2375,7 +2193,7 @@
                     <a:bodyPr/>
                     <a:lstStyle/>
                     <a:p>
-                      <a:pPr indent="0" marL="0">
+                      <a:pPr marL="0" indent="0">
                         <a:buNone/>
                       </a:pPr>
                       <a:r>
@@ -2396,7 +2214,7 @@
                       </a:endParaRPr>
                     </a:p>
                   </a:txBody>
-                  <a:tcPr marL="91440" marR="91440" marT="45720" marB="45720" anchor="ctr">
+                  <a:tcPr anchor="ctr">
                     <a:lnL w="12700" cap="flat" cmpd="sng" algn="ctr">
                       <a:solidFill>
                         <a:srgbClr val="0E1117"/>
@@ -2443,7 +2261,7 @@
                     <a:bodyPr/>
                     <a:lstStyle/>
                     <a:p>
-                      <a:pPr indent="0" marL="0">
+                      <a:pPr marL="0" indent="0">
                         <a:buNone/>
                       </a:pPr>
                       <a:r>
@@ -2464,7 +2282,7 @@
                       </a:endParaRPr>
                     </a:p>
                   </a:txBody>
-                  <a:tcPr marL="91440" marR="91440" marT="45720" marB="45720" anchor="ctr">
+                  <a:tcPr anchor="ctr">
                     <a:lnL w="12700" cap="flat" cmpd="sng" algn="ctr">
                       <a:solidFill>
                         <a:srgbClr val="0E1117"/>
@@ -2506,6 +2324,11 @@
                     </a:solidFill>
                   </a:tcPr>
                 </a:tc>
+                <a:extLst>
+                  <a:ext uri="{0D108BD9-81ED-4DB2-BD59-A6C34878D82A}">
+                    <a16:rowId xmlns:a16="http://schemas.microsoft.com/office/drawing/2014/main" val="10003"/>
+                  </a:ext>
+                </a:extLst>
               </a:tr>
             </a:tbl>
           </a:graphicData>
@@ -2602,6 +2425,7 @@
         <a:solidFill>
           <a:srgbClr val="0E1117"/>
         </a:solidFill>
+        <a:effectLst/>
       </p:bgPr>
     </p:bg>
     <p:spTree>
@@ -2639,7 +2463,7 @@
           <a:bodyPr wrap="square" lIns="0" tIns="0" rIns="0" bIns="0" rtlCol="0" anchor="ctr"/>
           <a:lstStyle/>
           <a:p>
-            <a:pPr indent="0" marL="0">
+            <a:pPr marL="0" indent="0">
               <a:buNone/>
             </a:pPr>
             <a:r>
@@ -2705,7 +2529,7 @@
           <a:bodyPr wrap="square" lIns="0" tIns="0" rIns="0" bIns="0" rtlCol="0" anchor="ctr"/>
           <a:lstStyle/>
           <a:p>
-            <a:pPr algn="ctr" indent="0" marL="0">
+            <a:pPr marL="0" indent="0" algn="ctr">
               <a:buNone/>
             </a:pPr>
             <a:r>
@@ -2717,7 +2541,7 @@
                 <a:ea typeface="Cambria" pitchFamily="34" charset="-122"/>
                 <a:cs typeface="Cambria" pitchFamily="34" charset="-120"/>
               </a:rPr>
-              <a:t>10</a:t>
+              <a:t>12</a:t>
             </a:r>
             <a:endParaRPr lang="en-US" sz="6000" dirty="0"/>
           </a:p>
@@ -2744,7 +2568,7 @@
           <a:bodyPr wrap="square" lIns="0" tIns="0" rIns="0" bIns="0" rtlCol="0" anchor="ctr"/>
           <a:lstStyle/>
           <a:p>
-            <a:pPr algn="ctr" indent="0" marL="0">
+            <a:pPr marL="0" indent="0" algn="ctr">
               <a:buNone/>
             </a:pPr>
             <a:r>
@@ -2807,7 +2631,7 @@
           <a:bodyPr wrap="square" lIns="0" tIns="0" rIns="0" bIns="0" rtlCol="0" anchor="ctr"/>
           <a:lstStyle/>
           <a:p>
-            <a:pPr algn="ctr" indent="0" marL="0">
+            <a:pPr marL="0" indent="0" algn="ctr">
               <a:buNone/>
             </a:pPr>
             <a:r>
@@ -2846,7 +2670,7 @@
           <a:bodyPr wrap="square" lIns="0" tIns="0" rIns="0" bIns="0" rtlCol="0" anchor="ctr"/>
           <a:lstStyle/>
           <a:p>
-            <a:pPr algn="ctr" indent="0" marL="0">
+            <a:pPr marL="0" indent="0" algn="ctr">
               <a:buNone/>
             </a:pPr>
             <a:r>
@@ -2909,7 +2733,7 @@
           <a:bodyPr wrap="square" lIns="0" tIns="0" rIns="0" bIns="0" rtlCol="0" anchor="ctr"/>
           <a:lstStyle/>
           <a:p>
-            <a:pPr algn="ctr" indent="0" marL="0">
+            <a:pPr marL="0" indent="0" algn="ctr">
               <a:buNone/>
             </a:pPr>
             <a:r>
@@ -2948,7 +2772,7 @@
           <a:bodyPr wrap="square" lIns="0" tIns="0" rIns="0" bIns="0" rtlCol="0" anchor="ctr"/>
           <a:lstStyle/>
           <a:p>
-            <a:pPr algn="ctr" indent="0" marL="0">
+            <a:pPr marL="0" indent="0" algn="ctr">
               <a:buNone/>
             </a:pPr>
             <a:r>
@@ -2984,7 +2808,7 @@
           <a:bodyPr wrap="square" lIns="0" tIns="0" rIns="0" bIns="0" rtlCol="0" anchor="ctr"/>
           <a:lstStyle/>
           <a:p>
-            <a:pPr indent="0" marL="0">
+            <a:pPr marL="0" indent="0">
               <a:buNone/>
             </a:pPr>
             <a:r>
@@ -3015,6 +2839,7 @@
         <a:solidFill>
           <a:srgbClr val="0E1117"/>
         </a:solidFill>
+        <a:effectLst/>
       </p:bgPr>
     </p:bg>
     <p:spTree>
@@ -3052,7 +2877,7 @@
           <a:bodyPr wrap="square" lIns="0" tIns="0" rIns="0" bIns="0" rtlCol="0" anchor="ctr"/>
           <a:lstStyle/>
           <a:p>
-            <a:pPr indent="0" marL="0">
+            <a:pPr marL="0" indent="0">
               <a:buNone/>
             </a:pPr>
             <a:r>
@@ -3118,7 +2943,7 @@
           <a:bodyPr wrap="square" lIns="0" tIns="0" rIns="0" bIns="0" rtlCol="0" anchor="t"/>
           <a:lstStyle/>
           <a:p>
-            <a:pPr indent="0" marL="0">
+            <a:pPr marL="0" indent="0">
               <a:buNone/>
             </a:pPr>
             <a:r>
@@ -3290,7 +3115,7 @@
           <a:bodyPr wrap="square" lIns="0" tIns="0" rIns="0" bIns="0" rtlCol="0" anchor="t"/>
           <a:lstStyle/>
           <a:p>
-            <a:pPr indent="0" marL="0">
+            <a:pPr marL="0" indent="0">
               <a:buNone/>
             </a:pPr>
             <a:r>
@@ -3430,6 +3255,7 @@
         <a:solidFill>
           <a:srgbClr val="0E1117"/>
         </a:solidFill>
+        <a:effectLst/>
       </p:bgPr>
     </p:bg>
     <p:spTree>
@@ -3467,7 +3293,7 @@
           <a:bodyPr wrap="square" lIns="0" tIns="0" rIns="0" bIns="0" rtlCol="0" anchor="ctr"/>
           <a:lstStyle/>
           <a:p>
-            <a:pPr indent="0" marL="0">
+            <a:pPr marL="0" indent="0">
               <a:buNone/>
             </a:pPr>
             <a:r>
@@ -3533,7 +3359,7 @@
           <a:bodyPr wrap="square" lIns="0" tIns="0" rIns="0" bIns="0" rtlCol="0" anchor="ctr"/>
           <a:lstStyle/>
           <a:p>
-            <a:pPr algn="ctr" indent="0" marL="0">
+            <a:pPr marL="0" indent="0" algn="ctr">
               <a:buNone/>
             </a:pPr>
             <a:r>
@@ -3596,7 +3422,7 @@
           <a:bodyPr wrap="square" lIns="0" tIns="0" rIns="0" bIns="0" rtlCol="0" anchor="ctr"/>
           <a:lstStyle/>
           <a:p>
-            <a:pPr algn="ctr" indent="0" marL="0">
+            <a:pPr marL="0" indent="0" algn="ctr">
               <a:buNone/>
             </a:pPr>
             <a:r>
@@ -3659,7 +3485,7 @@
           <a:bodyPr wrap="square" lIns="0" tIns="0" rIns="0" bIns="0" rtlCol="0" anchor="ctr"/>
           <a:lstStyle/>
           <a:p>
-            <a:pPr algn="ctr" indent="0" marL="0">
+            <a:pPr marL="0" indent="0" algn="ctr">
               <a:buNone/>
             </a:pPr>
             <a:r>
@@ -3722,7 +3548,7 @@
           <a:bodyPr wrap="square" lIns="0" tIns="0" rIns="0" bIns="0" rtlCol="0" anchor="ctr"/>
           <a:lstStyle/>
           <a:p>
-            <a:pPr algn="ctr" indent="0" marL="0">
+            <a:pPr marL="0" indent="0" algn="ctr">
               <a:buNone/>
             </a:pPr>
             <a:r>
@@ -3785,7 +3611,7 @@
           <a:bodyPr wrap="square" lIns="0" tIns="0" rIns="0" bIns="0" rtlCol="0" anchor="ctr"/>
           <a:lstStyle/>
           <a:p>
-            <a:pPr algn="ctr" indent="0" marL="0">
+            <a:pPr marL="0" indent="0" algn="ctr">
               <a:buNone/>
             </a:pPr>
             <a:r>
@@ -3848,7 +3674,7 @@
           <a:bodyPr wrap="square" lIns="0" tIns="0" rIns="0" bIns="0" rtlCol="0" anchor="ctr"/>
           <a:lstStyle/>
           <a:p>
-            <a:pPr algn="ctr" indent="0" marL="0">
+            <a:pPr marL="0" indent="0" algn="ctr">
               <a:buNone/>
             </a:pPr>
             <a:r>
@@ -3884,7 +3710,7 @@
           <a:bodyPr wrap="square" lIns="0" tIns="0" rIns="0" bIns="0" rtlCol="0" anchor="ctr"/>
           <a:lstStyle/>
           <a:p>
-            <a:pPr indent="0" marL="0">
+            <a:pPr marL="0" indent="0">
               <a:buNone/>
             </a:pPr>
             <a:r>
@@ -3923,7 +3749,7 @@
           <a:bodyPr wrap="square" lIns="0" tIns="0" rIns="0" bIns="0" rtlCol="0" anchor="ctr"/>
           <a:lstStyle/>
           <a:p>
-            <a:pPr indent="0" marL="0">
+            <a:pPr marL="0" indent="0">
               <a:buNone/>
             </a:pPr>
             <a:r>
@@ -3954,6 +3780,7 @@
         <a:solidFill>
           <a:srgbClr val="0E1117"/>
         </a:solidFill>
+        <a:effectLst/>
       </p:bgPr>
     </p:bg>
     <p:spTree>
@@ -3991,7 +3818,7 @@
           <a:bodyPr wrap="square" lIns="0" tIns="0" rIns="0" bIns="0" rtlCol="0" anchor="ctr"/>
           <a:lstStyle/>
           <a:p>
-            <a:pPr indent="0" marL="0">
+            <a:pPr marL="0" indent="0">
               <a:buNone/>
             </a:pPr>
             <a:r>
@@ -4057,7 +3884,7 @@
           <a:bodyPr wrap="square" lIns="0" tIns="0" rIns="0" bIns="0" rtlCol="0" anchor="t"/>
           <a:lstStyle/>
           <a:p>
-            <a:pPr indent="0" marL="0">
+            <a:pPr marL="0" indent="0">
               <a:buNone/>
             </a:pPr>
             <a:r>
@@ -4208,7 +4035,7 @@
           <a:bodyPr wrap="square" lIns="0" tIns="0" rIns="0" bIns="0" rtlCol="0" anchor="t"/>
           <a:lstStyle/>
           <a:p>
-            <a:pPr indent="0" marL="0">
+            <a:pPr marL="0" indent="0">
               <a:buNone/>
             </a:pPr>
             <a:r>
@@ -4348,6 +4175,7 @@
         <a:solidFill>
           <a:srgbClr val="0E1117"/>
         </a:solidFill>
+        <a:effectLst/>
       </p:bgPr>
     </p:bg>
     <p:spTree>
@@ -4385,7 +4213,7 @@
           <a:bodyPr wrap="square" lIns="0" tIns="0" rIns="0" bIns="0" rtlCol="0" anchor="ctr"/>
           <a:lstStyle/>
           <a:p>
-            <a:pPr indent="0" marL="0">
+            <a:pPr marL="0" indent="0">
               <a:buNone/>
             </a:pPr>
             <a:r>
@@ -4451,7 +4279,7 @@
           <a:bodyPr wrap="square" lIns="0" tIns="0" rIns="0" bIns="0" rtlCol="0" anchor="t"/>
           <a:lstStyle/>
           <a:p>
-            <a:pPr indent="0" marL="0">
+            <a:pPr marL="0" indent="0">
               <a:buNone/>
             </a:pPr>
             <a:r>
@@ -4490,7 +4318,7 @@
           <a:bodyPr wrap="square" lIns="0" tIns="0" rIns="0" bIns="0" rtlCol="0" anchor="t"/>
           <a:lstStyle/>
           <a:p>
-            <a:pPr indent="0" marL="0">
+            <a:pPr marL="0" indent="0">
               <a:buNone/>
             </a:pPr>
             <a:r>
@@ -4556,7 +4384,7 @@
           <a:bodyPr wrap="square" lIns="0" tIns="0" rIns="0" bIns="0" rtlCol="0" anchor="t"/>
           <a:lstStyle/>
           <a:p>
-            <a:pPr indent="0" marL="0">
+            <a:pPr marL="0" indent="0">
               <a:buNone/>
             </a:pPr>
             <a:r>
@@ -4595,7 +4423,7 @@
           <a:bodyPr wrap="square" lIns="0" tIns="0" rIns="0" bIns="0" rtlCol="0" anchor="t"/>
           <a:lstStyle/>
           <a:p>
-            <a:pPr indent="0" marL="0">
+            <a:pPr marL="0" indent="0">
               <a:buNone/>
             </a:pPr>
             <a:r>
@@ -4661,7 +4489,7 @@
           <a:bodyPr wrap="square" lIns="0" tIns="0" rIns="0" bIns="0" rtlCol="0" anchor="t"/>
           <a:lstStyle/>
           <a:p>
-            <a:pPr indent="0" marL="0">
+            <a:pPr marL="0" indent="0">
               <a:buNone/>
             </a:pPr>
             <a:r>
@@ -4700,7 +4528,7 @@
           <a:bodyPr wrap="square" lIns="0" tIns="0" rIns="0" bIns="0" rtlCol="0" anchor="t"/>
           <a:lstStyle/>
           <a:p>
-            <a:pPr indent="0" marL="0">
+            <a:pPr marL="0" indent="0">
               <a:buNone/>
             </a:pPr>
             <a:r>
@@ -4766,7 +4594,7 @@
           <a:bodyPr wrap="square" lIns="0" tIns="0" rIns="0" bIns="0" rtlCol="0" anchor="t"/>
           <a:lstStyle/>
           <a:p>
-            <a:pPr indent="0" marL="0">
+            <a:pPr marL="0" indent="0">
               <a:buNone/>
             </a:pPr>
             <a:r>
@@ -4805,7 +4633,7 @@
           <a:bodyPr wrap="square" lIns="0" tIns="0" rIns="0" bIns="0" rtlCol="0" anchor="t"/>
           <a:lstStyle/>
           <a:p>
-            <a:pPr indent="0" marL="0">
+            <a:pPr marL="0" indent="0">
               <a:buNone/>
             </a:pPr>
             <a:r>
@@ -4839,6 +4667,7 @@
         <a:solidFill>
           <a:srgbClr val="0E1117"/>
         </a:solidFill>
+        <a:effectLst/>
       </p:bgPr>
     </p:bg>
     <p:spTree>
@@ -4876,7 +4705,7 @@
           <a:bodyPr wrap="square" lIns="0" tIns="0" rIns="0" bIns="0" rtlCol="0" anchor="ctr"/>
           <a:lstStyle/>
           <a:p>
-            <a:pPr indent="0" marL="0">
+            <a:pPr marL="0" indent="0">
               <a:buNone/>
             </a:pPr>
             <a:r>
@@ -4942,7 +4771,7 @@
           <a:bodyPr wrap="square" lIns="0" tIns="0" rIns="0" bIns="0" rtlCol="0" anchor="t"/>
           <a:lstStyle/>
           <a:p>
-            <a:pPr indent="0" marL="0">
+            <a:pPr marL="0" indent="0">
               <a:buNone/>
             </a:pPr>
             <a:r>
@@ -4981,7 +4810,7 @@
           <a:bodyPr wrap="square" lIns="0" tIns="0" rIns="0" bIns="0" rtlCol="0" anchor="t"/>
           <a:lstStyle/>
           <a:p>
-            <a:pPr indent="0" marL="0">
+            <a:pPr marL="0" indent="0">
               <a:buNone/>
             </a:pPr>
             <a:r>
@@ -5047,7 +4876,7 @@
           <a:bodyPr wrap="square" lIns="0" tIns="0" rIns="0" bIns="0" rtlCol="0" anchor="t"/>
           <a:lstStyle/>
           <a:p>
-            <a:pPr indent="0" marL="0">
+            <a:pPr marL="0" indent="0">
               <a:buNone/>
             </a:pPr>
             <a:r>
@@ -5086,7 +4915,7 @@
           <a:bodyPr wrap="square" lIns="0" tIns="0" rIns="0" bIns="0" rtlCol="0" anchor="t"/>
           <a:lstStyle/>
           <a:p>
-            <a:pPr indent="0" marL="0">
+            <a:pPr marL="0" indent="0">
               <a:buNone/>
             </a:pPr>
             <a:r>
@@ -5152,7 +4981,7 @@
           <a:bodyPr wrap="square" lIns="0" tIns="0" rIns="0" bIns="0" rtlCol="0" anchor="t"/>
           <a:lstStyle/>
           <a:p>
-            <a:pPr indent="0" marL="0">
+            <a:pPr marL="0" indent="0">
               <a:buNone/>
             </a:pPr>
             <a:r>
@@ -5191,7 +5020,7 @@
           <a:bodyPr wrap="square" lIns="0" tIns="0" rIns="0" bIns="0" rtlCol="0" anchor="t"/>
           <a:lstStyle/>
           <a:p>
-            <a:pPr indent="0" marL="0">
+            <a:pPr marL="0" indent="0">
               <a:buNone/>
             </a:pPr>
             <a:r>
@@ -5257,7 +5086,7 @@
           <a:bodyPr wrap="square" lIns="0" tIns="0" rIns="0" bIns="0" rtlCol="0" anchor="t"/>
           <a:lstStyle/>
           <a:p>
-            <a:pPr indent="0" marL="0">
+            <a:pPr marL="0" indent="0">
               <a:buNone/>
             </a:pPr>
             <a:r>
@@ -5296,7 +5125,7 @@
           <a:bodyPr wrap="square" lIns="0" tIns="0" rIns="0" bIns="0" rtlCol="0" anchor="t"/>
           <a:lstStyle/>
           <a:p>
-            <a:pPr indent="0" marL="0">
+            <a:pPr marL="0" indent="0">
               <a:buNone/>
             </a:pPr>
             <a:r>
@@ -5330,6 +5159,7 @@
         <a:solidFill>
           <a:srgbClr val="0E1117"/>
         </a:solidFill>
+        <a:effectLst/>
       </p:bgPr>
     </p:bg>
     <p:spTree>
@@ -5367,7 +5197,7 @@
           <a:bodyPr wrap="square" lIns="0" tIns="0" rIns="0" bIns="0" rtlCol="0" anchor="ctr"/>
           <a:lstStyle/>
           <a:p>
-            <a:pPr indent="0" marL="0">
+            <a:pPr marL="0" indent="0">
               <a:buNone/>
             </a:pPr>
             <a:r>
@@ -5433,7 +5263,7 @@
           <a:bodyPr wrap="square" lIns="0" tIns="0" rIns="0" bIns="0" rtlCol="0" anchor="ctr"/>
           <a:lstStyle/>
           <a:p>
-            <a:pPr algn="ctr" indent="0" marL="0">
+            <a:pPr marL="0" indent="0" algn="ctr">
               <a:buNone/>
             </a:pPr>
             <a:r>
@@ -5472,7 +5302,7 @@
           <a:bodyPr wrap="square" lIns="0" tIns="0" rIns="0" bIns="0" rtlCol="0" anchor="t"/>
           <a:lstStyle/>
           <a:p>
-            <a:pPr algn="ctr" indent="0" marL="0">
+            <a:pPr marL="0" indent="0" algn="ctr">
               <a:buNone/>
             </a:pPr>
             <a:r>
@@ -5535,7 +5365,7 @@
           <a:bodyPr wrap="square" lIns="0" tIns="0" rIns="0" bIns="0" rtlCol="0" anchor="ctr"/>
           <a:lstStyle/>
           <a:p>
-            <a:pPr algn="ctr" indent="0" marL="0">
+            <a:pPr marL="0" indent="0" algn="ctr">
               <a:buNone/>
             </a:pPr>
             <a:r>
@@ -5574,7 +5404,7 @@
           <a:bodyPr wrap="square" lIns="0" tIns="0" rIns="0" bIns="0" rtlCol="0" anchor="t"/>
           <a:lstStyle/>
           <a:p>
-            <a:pPr algn="ctr" indent="0" marL="0">
+            <a:pPr marL="0" indent="0" algn="ctr">
               <a:buNone/>
             </a:pPr>
             <a:r>
@@ -5637,7 +5467,7 @@
           <a:bodyPr wrap="square" lIns="0" tIns="0" rIns="0" bIns="0" rtlCol="0" anchor="ctr"/>
           <a:lstStyle/>
           <a:p>
-            <a:pPr algn="ctr" indent="0" marL="0">
+            <a:pPr marL="0" indent="0" algn="ctr">
               <a:buNone/>
             </a:pPr>
             <a:r>
@@ -5676,7 +5506,7 @@
           <a:bodyPr wrap="square" lIns="0" tIns="0" rIns="0" bIns="0" rtlCol="0" anchor="t"/>
           <a:lstStyle/>
           <a:p>
-            <a:pPr algn="ctr" indent="0" marL="0">
+            <a:pPr marL="0" indent="0" algn="ctr">
               <a:buNone/>
             </a:pPr>
             <a:r>
@@ -5739,7 +5569,7 @@
           <a:bodyPr wrap="square" lIns="0" tIns="0" rIns="0" bIns="0" rtlCol="0" anchor="ctr"/>
           <a:lstStyle/>
           <a:p>
-            <a:pPr algn="ctr" indent="0" marL="0">
+            <a:pPr marL="0" indent="0" algn="ctr">
               <a:buNone/>
             </a:pPr>
             <a:r>
@@ -5778,7 +5608,7 @@
           <a:bodyPr wrap="square" lIns="0" tIns="0" rIns="0" bIns="0" rtlCol="0" anchor="t"/>
           <a:lstStyle/>
           <a:p>
-            <a:pPr algn="ctr" indent="0" marL="0">
+            <a:pPr marL="0" indent="0" algn="ctr">
               <a:buNone/>
             </a:pPr>
             <a:r>
@@ -5841,7 +5671,7 @@
           <a:bodyPr wrap="square" lIns="0" tIns="0" rIns="0" bIns="0" rtlCol="0" anchor="ctr"/>
           <a:lstStyle/>
           <a:p>
-            <a:pPr algn="ctr" indent="0" marL="0">
+            <a:pPr marL="0" indent="0" algn="ctr">
               <a:buNone/>
             </a:pPr>
             <a:r>
@@ -5880,7 +5710,7 @@
           <a:bodyPr wrap="square" lIns="0" tIns="0" rIns="0" bIns="0" rtlCol="0" anchor="t"/>
           <a:lstStyle/>
           <a:p>
-            <a:pPr algn="ctr" indent="0" marL="0">
+            <a:pPr marL="0" indent="0" algn="ctr">
               <a:buNone/>
             </a:pPr>
             <a:r>
@@ -5943,7 +5773,7 @@
           <a:bodyPr wrap="square" lIns="0" tIns="0" rIns="0" bIns="0" rtlCol="0" anchor="ctr"/>
           <a:lstStyle/>
           <a:p>
-            <a:pPr algn="ctr" indent="0" marL="0">
+            <a:pPr marL="0" indent="0" algn="ctr">
               <a:buNone/>
             </a:pPr>
             <a:r>
@@ -5982,7 +5812,7 @@
           <a:bodyPr wrap="square" lIns="0" tIns="0" rIns="0" bIns="0" rtlCol="0" anchor="t"/>
           <a:lstStyle/>
           <a:p>
-            <a:pPr algn="ctr" indent="0" marL="0">
+            <a:pPr marL="0" indent="0" algn="ctr">
               <a:buNone/>
             </a:pPr>
             <a:r>
@@ -6018,7 +5848,7 @@
           <a:bodyPr wrap="square" lIns="0" tIns="0" rIns="0" bIns="0" rtlCol="0" anchor="ctr"/>
           <a:lstStyle/>
           <a:p>
-            <a:pPr indent="0" marL="0">
+            <a:pPr marL="0" indent="0">
               <a:buNone/>
             </a:pPr>
             <a:r>
@@ -6049,6 +5879,7 @@
         <a:solidFill>
           <a:srgbClr val="0E1117"/>
         </a:solidFill>
+        <a:effectLst/>
       </p:bgPr>
     </p:bg>
     <p:spTree>
@@ -6086,7 +5917,7 @@
           <a:bodyPr wrap="square" lIns="0" tIns="0" rIns="0" bIns="0" rtlCol="0" anchor="ctr"/>
           <a:lstStyle/>
           <a:p>
-            <a:pPr indent="0" marL="0">
+            <a:pPr marL="0" indent="0">
               <a:buNone/>
             </a:pPr>
             <a:r>
@@ -6152,7 +5983,7 @@
           <a:bodyPr wrap="square" lIns="0" tIns="0" rIns="0" bIns="0" rtlCol="0" anchor="t"/>
           <a:lstStyle/>
           <a:p>
-            <a:pPr indent="0" marL="0">
+            <a:pPr marL="0" indent="0">
               <a:buNone/>
             </a:pPr>
             <a:r>
@@ -6191,7 +6022,7 @@
           <a:bodyPr wrap="square" lIns="0" tIns="0" rIns="0" bIns="0" rtlCol="0" anchor="t"/>
           <a:lstStyle/>
           <a:p>
-            <a:pPr indent="0" marL="0">
+            <a:pPr marL="0" indent="0">
               <a:buNone/>
             </a:pPr>
             <a:r>
@@ -6257,7 +6088,7 @@
           <a:bodyPr wrap="square" lIns="0" tIns="0" rIns="0" bIns="0" rtlCol="0" anchor="t"/>
           <a:lstStyle/>
           <a:p>
-            <a:pPr indent="0" marL="0">
+            <a:pPr marL="0" indent="0">
               <a:buNone/>
             </a:pPr>
             <a:r>
@@ -6296,7 +6127,7 @@
           <a:bodyPr wrap="square" lIns="0" tIns="0" rIns="0" bIns="0" rtlCol="0" anchor="t"/>
           <a:lstStyle/>
           <a:p>
-            <a:pPr indent="0" marL="0">
+            <a:pPr marL="0" indent="0">
               <a:buNone/>
             </a:pPr>
             <a:r>
@@ -6362,7 +6193,7 @@
           <a:bodyPr wrap="square" lIns="0" tIns="0" rIns="0" bIns="0" rtlCol="0" anchor="t"/>
           <a:lstStyle/>
           <a:p>
-            <a:pPr indent="0" marL="0">
+            <a:pPr marL="0" indent="0">
               <a:buNone/>
             </a:pPr>
             <a:r>
@@ -6401,7 +6232,7 @@
           <a:bodyPr wrap="square" lIns="0" tIns="0" rIns="0" bIns="0" rtlCol="0" anchor="t"/>
           <a:lstStyle/>
           <a:p>
-            <a:pPr indent="0" marL="0">
+            <a:pPr marL="0" indent="0">
               <a:buNone/>
             </a:pPr>
             <a:r>
@@ -6440,7 +6271,7 @@
           <a:bodyPr wrap="square" lIns="0" tIns="0" rIns="0" bIns="0" rtlCol="0" anchor="t"/>
           <a:lstStyle/>
           <a:p>
-            <a:pPr indent="0" marL="0">
+            <a:pPr marL="0" indent="0">
               <a:buNone/>
             </a:pPr>
             <a:r>
@@ -6471,6 +6302,7 @@
         <a:solidFill>
           <a:srgbClr val="0E1117"/>
         </a:solidFill>
+        <a:effectLst/>
       </p:bgPr>
     </p:bg>
     <p:spTree>
@@ -6508,7 +6340,7 @@
           <a:bodyPr wrap="square" lIns="0" tIns="0" rIns="0" bIns="0" rtlCol="0" anchor="ctr"/>
           <a:lstStyle/>
           <a:p>
-            <a:pPr indent="0" marL="0">
+            <a:pPr marL="0" indent="0">
               <a:buNone/>
             </a:pPr>
             <a:r>
@@ -6574,7 +6406,7 @@
           <a:bodyPr wrap="square" lIns="0" tIns="0" rIns="0" bIns="0" rtlCol="0" anchor="ctr"/>
           <a:lstStyle/>
           <a:p>
-            <a:pPr algn="ctr" indent="0" marL="0">
+            <a:pPr marL="0" indent="0" algn="ctr">
               <a:buNone/>
             </a:pPr>
             <a:r>
@@ -6613,7 +6445,7 @@
           <a:bodyPr wrap="square" lIns="0" tIns="0" rIns="0" bIns="0" rtlCol="0" anchor="ctr"/>
           <a:lstStyle/>
           <a:p>
-            <a:pPr algn="ctr" indent="0" marL="0">
+            <a:pPr marL="0" indent="0" algn="ctr">
               <a:buNone/>
             </a:pPr>
             <a:r>
@@ -6676,7 +6508,7 @@
           <a:bodyPr wrap="square" lIns="0" tIns="0" rIns="0" bIns="0" rtlCol="0" anchor="ctr"/>
           <a:lstStyle/>
           <a:p>
-            <a:pPr algn="ctr" indent="0" marL="0">
+            <a:pPr marL="0" indent="0" algn="ctr">
               <a:buNone/>
             </a:pPr>
             <a:r>
@@ -6715,7 +6547,7 @@
           <a:bodyPr wrap="square" lIns="0" tIns="0" rIns="0" bIns="0" rtlCol="0" anchor="ctr"/>
           <a:lstStyle/>
           <a:p>
-            <a:pPr algn="ctr" indent="0" marL="0">
+            <a:pPr marL="0" indent="0" algn="ctr">
               <a:buNone/>
             </a:pPr>
             <a:r>
@@ -6778,7 +6610,7 @@
           <a:bodyPr wrap="square" lIns="0" tIns="0" rIns="0" bIns="0" rtlCol="0" anchor="ctr"/>
           <a:lstStyle/>
           <a:p>
-            <a:pPr algn="ctr" indent="0" marL="0">
+            <a:pPr marL="0" indent="0" algn="ctr">
               <a:buNone/>
             </a:pPr>
             <a:r>
@@ -6817,7 +6649,7 @@
           <a:bodyPr wrap="square" lIns="0" tIns="0" rIns="0" bIns="0" rtlCol="0" anchor="ctr"/>
           <a:lstStyle/>
           <a:p>
-            <a:pPr algn="ctr" indent="0" marL="0">
+            <a:pPr marL="0" indent="0" algn="ctr">
               <a:buNone/>
             </a:pPr>
             <a:r>
@@ -6853,7 +6685,7 @@
           <a:bodyPr wrap="square" lIns="0" tIns="0" rIns="0" bIns="0" rtlCol="0" anchor="ctr"/>
           <a:lstStyle/>
           <a:p>
-            <a:pPr indent="0" marL="0">
+            <a:pPr marL="0" indent="0">
               <a:buNone/>
             </a:pPr>
             <a:r>
@@ -6884,6 +6716,7 @@
         <a:solidFill>
           <a:srgbClr val="0E1117"/>
         </a:solidFill>
+        <a:effectLst/>
       </p:bgPr>
     </p:bg>
     <p:spTree>
@@ -6921,7 +6754,7 @@
           <a:bodyPr wrap="square" lIns="0" tIns="0" rIns="0" bIns="0" rtlCol="0" anchor="ctr"/>
           <a:lstStyle/>
           <a:p>
-            <a:pPr indent="0" marL="0">
+            <a:pPr marL="0" indent="0">
               <a:buNone/>
             </a:pPr>
             <a:r>
@@ -6987,7 +6820,7 @@
           <a:bodyPr wrap="square" lIns="0" tIns="0" rIns="0" bIns="0" rtlCol="0" anchor="t"/>
           <a:lstStyle/>
           <a:p>
-            <a:pPr indent="0" marL="0">
+            <a:pPr marL="0" indent="0">
               <a:buNone/>
             </a:pPr>
             <a:r>
@@ -7026,7 +6859,7 @@
           <a:bodyPr wrap="square" lIns="0" tIns="0" rIns="0" bIns="0" rtlCol="0" anchor="t"/>
           <a:lstStyle/>
           <a:p>
-            <a:pPr indent="0" marL="0">
+            <a:pPr marL="0" indent="0">
               <a:buNone/>
             </a:pPr>
             <a:r>
@@ -7092,7 +6925,7 @@
           <a:bodyPr wrap="square" lIns="0" tIns="0" rIns="0" bIns="0" rtlCol="0" anchor="t"/>
           <a:lstStyle/>
           <a:p>
-            <a:pPr indent="0" marL="0">
+            <a:pPr marL="0" indent="0">
               <a:buNone/>
             </a:pPr>
             <a:r>
@@ -7131,7 +6964,7 @@
           <a:bodyPr wrap="square" lIns="0" tIns="0" rIns="0" bIns="0" rtlCol="0" anchor="t"/>
           <a:lstStyle/>
           <a:p>
-            <a:pPr indent="0" marL="0">
+            <a:pPr marL="0" indent="0">
               <a:buNone/>
             </a:pPr>
             <a:r>
@@ -7197,7 +7030,7 @@
           <a:bodyPr wrap="square" lIns="0" tIns="0" rIns="0" bIns="0" rtlCol="0" anchor="t"/>
           <a:lstStyle/>
           <a:p>
-            <a:pPr indent="0" marL="0">
+            <a:pPr marL="0" indent="0">
               <a:buNone/>
             </a:pPr>
             <a:r>
@@ -7236,7 +7069,7 @@
           <a:bodyPr wrap="square" lIns="0" tIns="0" rIns="0" bIns="0" rtlCol="0" anchor="t"/>
           <a:lstStyle/>
           <a:p>
-            <a:pPr indent="0" marL="0">
+            <a:pPr marL="0" indent="0">
               <a:buNone/>
             </a:pPr>
             <a:r>
@@ -7302,7 +7135,7 @@
           <a:bodyPr wrap="square" lIns="0" tIns="0" rIns="0" bIns="0" rtlCol="0" anchor="t"/>
           <a:lstStyle/>
           <a:p>
-            <a:pPr indent="0" marL="0">
+            <a:pPr marL="0" indent="0">
               <a:buNone/>
             </a:pPr>
             <a:r>
@@ -7341,7 +7174,7 @@
           <a:bodyPr wrap="square" lIns="0" tIns="0" rIns="0" bIns="0" rtlCol="0" anchor="t"/>
           <a:lstStyle/>
           <a:p>
-            <a:pPr indent="0" marL="0">
+            <a:pPr marL="0" indent="0">
               <a:buNone/>
             </a:pPr>
             <a:r>
@@ -7407,7 +7240,7 @@
           <a:bodyPr wrap="square" lIns="0" tIns="0" rIns="0" bIns="0" rtlCol="0" anchor="t"/>
           <a:lstStyle/>
           <a:p>
-            <a:pPr indent="0" marL="0">
+            <a:pPr marL="0" indent="0">
               <a:buNone/>
             </a:pPr>
             <a:r>
@@ -7446,7 +7279,7 @@
           <a:bodyPr wrap="square" lIns="0" tIns="0" rIns="0" bIns="0" rtlCol="0" anchor="t"/>
           <a:lstStyle/>
           <a:p>
-            <a:pPr indent="0" marL="0">
+            <a:pPr marL="0" indent="0">
               <a:buNone/>
             </a:pPr>
             <a:r>
@@ -7512,7 +7345,7 @@
           <a:bodyPr wrap="square" lIns="0" tIns="0" rIns="0" bIns="0" rtlCol="0" anchor="t"/>
           <a:lstStyle/>
           <a:p>
-            <a:pPr indent="0" marL="0">
+            <a:pPr marL="0" indent="0">
               <a:buNone/>
             </a:pPr>
             <a:r>
@@ -7551,7 +7384,7 @@
           <a:bodyPr wrap="square" lIns="0" tIns="0" rIns="0" bIns="0" rtlCol="0" anchor="t"/>
           <a:lstStyle/>
           <a:p>
-            <a:pPr indent="0" marL="0">
+            <a:pPr marL="0" indent="0">
               <a:buNone/>
             </a:pPr>
             <a:r>
@@ -7585,6 +7418,7 @@
         <a:solidFill>
           <a:srgbClr val="0E1117"/>
         </a:solidFill>
+        <a:effectLst/>
       </p:bgPr>
     </p:bg>
     <p:spTree>
@@ -7622,7 +7456,7 @@
           <a:bodyPr wrap="square" lIns="0" tIns="0" rIns="0" bIns="0" rtlCol="0" anchor="ctr"/>
           <a:lstStyle/>
           <a:p>
-            <a:pPr indent="0" marL="0">
+            <a:pPr marL="0" indent="0">
               <a:buNone/>
             </a:pPr>
             <a:r>
@@ -7663,8 +7497,20 @@
             <a:tbl>
               <a:tblPr/>
               <a:tblGrid>
-                <a:gridCol w="2377440"/>
-                <a:gridCol w="5852160"/>
+                <a:gridCol w="2377440">
+                  <a:extLst>
+                    <a:ext uri="{9D8B030D-6E8A-4147-A177-3AD203B41FA5}">
+                      <a16:colId xmlns:a16="http://schemas.microsoft.com/office/drawing/2014/main" val="20000"/>
+                    </a:ext>
+                  </a:extLst>
+                </a:gridCol>
+                <a:gridCol w="5852160">
+                  <a:extLst>
+                    <a:ext uri="{9D8B030D-6E8A-4147-A177-3AD203B41FA5}">
+                      <a16:colId xmlns:a16="http://schemas.microsoft.com/office/drawing/2014/main" val="20001"/>
+                    </a:ext>
+                  </a:extLst>
+                </a:gridCol>
               </a:tblGrid>
               <a:tr h="457200">
                 <a:tc>
@@ -7672,7 +7518,7 @@
                     <a:bodyPr/>
                     <a:lstStyle/>
                     <a:p>
-                      <a:pPr indent="0" marL="0">
+                      <a:pPr marL="0" indent="0">
                         <a:buNone/>
                       </a:pPr>
                       <a:r>
@@ -7693,7 +7539,7 @@
                       </a:endParaRPr>
                     </a:p>
                   </a:txBody>
-                  <a:tcPr marL="91440" marR="91440" marT="45720" marB="45720" anchor="ctr">
+                  <a:tcPr anchor="ctr">
                     <a:lnL w="12700" cap="flat" cmpd="sng" algn="ctr">
                       <a:solidFill>
                         <a:srgbClr val="0E1117"/>
@@ -7740,7 +7586,7 @@
                     <a:bodyPr/>
                     <a:lstStyle/>
                     <a:p>
-                      <a:pPr indent="0" marL="0">
+                      <a:pPr marL="0" indent="0">
                         <a:buNone/>
                       </a:pPr>
                       <a:r>
@@ -7761,7 +7607,7 @@
                       </a:endParaRPr>
                     </a:p>
                   </a:txBody>
-                  <a:tcPr marL="91440" marR="91440" marT="45720" marB="45720" anchor="ctr">
+                  <a:tcPr anchor="ctr">
                     <a:lnL w="12700" cap="flat" cmpd="sng" algn="ctr">
                       <a:solidFill>
                         <a:srgbClr val="0E1117"/>
@@ -7803,6 +7649,11 @@
                     </a:solidFill>
                   </a:tcPr>
                 </a:tc>
+                <a:extLst>
+                  <a:ext uri="{0D108BD9-81ED-4DB2-BD59-A6C34878D82A}">
+                    <a16:rowId xmlns:a16="http://schemas.microsoft.com/office/drawing/2014/main" val="10000"/>
+                  </a:ext>
+                </a:extLst>
               </a:tr>
               <a:tr h="457200">
                 <a:tc>
@@ -7810,7 +7661,7 @@
                     <a:bodyPr/>
                     <a:lstStyle/>
                     <a:p>
-                      <a:pPr indent="0" marL="0">
+                      <a:pPr marL="0" indent="0">
                         <a:buNone/>
                       </a:pPr>
                       <a:r>
@@ -7831,7 +7682,7 @@
                       </a:endParaRPr>
                     </a:p>
                   </a:txBody>
-                  <a:tcPr marL="91440" marR="91440" marT="45720" marB="45720" anchor="ctr">
+                  <a:tcPr anchor="ctr">
                     <a:lnL w="12700" cap="flat" cmpd="sng" algn="ctr">
                       <a:solidFill>
                         <a:srgbClr val="0E1117"/>
@@ -7878,7 +7729,7 @@
                     <a:bodyPr/>
                     <a:lstStyle/>
                     <a:p>
-                      <a:pPr indent="0" marL="0">
+                      <a:pPr marL="0" indent="0">
                         <a:buNone/>
                       </a:pPr>
                       <a:r>
@@ -7899,7 +7750,7 @@
                       </a:endParaRPr>
                     </a:p>
                   </a:txBody>
-                  <a:tcPr marL="91440" marR="91440" marT="45720" marB="45720" anchor="ctr">
+                  <a:tcPr anchor="ctr">
                     <a:lnL w="12700" cap="flat" cmpd="sng" algn="ctr">
                       <a:solidFill>
                         <a:srgbClr val="0E1117"/>
@@ -7941,6 +7792,11 @@
                     </a:solidFill>
                   </a:tcPr>
                 </a:tc>
+                <a:extLst>
+                  <a:ext uri="{0D108BD9-81ED-4DB2-BD59-A6C34878D82A}">
+                    <a16:rowId xmlns:a16="http://schemas.microsoft.com/office/drawing/2014/main" val="10001"/>
+                  </a:ext>
+                </a:extLst>
               </a:tr>
               <a:tr h="457200">
                 <a:tc>
@@ -7948,7 +7804,7 @@
                     <a:bodyPr/>
                     <a:lstStyle/>
                     <a:p>
-                      <a:pPr indent="0" marL="0">
+                      <a:pPr marL="0" indent="0">
                         <a:buNone/>
                       </a:pPr>
                       <a:r>
@@ -7969,7 +7825,7 @@
                       </a:endParaRPr>
                     </a:p>
                   </a:txBody>
-                  <a:tcPr marL="91440" marR="91440" marT="45720" marB="45720" anchor="ctr">
+                  <a:tcPr anchor="ctr">
                     <a:lnL w="12700" cap="flat" cmpd="sng" algn="ctr">
                       <a:solidFill>
                         <a:srgbClr val="0E1117"/>
@@ -8016,7 +7872,7 @@
                     <a:bodyPr/>
                     <a:lstStyle/>
                     <a:p>
-                      <a:pPr indent="0" marL="0">
+                      <a:pPr marL="0" indent="0">
                         <a:buNone/>
                       </a:pPr>
                       <a:r>
@@ -8037,7 +7893,7 @@
                       </a:endParaRPr>
                     </a:p>
                   </a:txBody>
-                  <a:tcPr marL="91440" marR="91440" marT="45720" marB="45720" anchor="ctr">
+                  <a:tcPr anchor="ctr">
                     <a:lnL w="12700" cap="flat" cmpd="sng" algn="ctr">
                       <a:solidFill>
                         <a:srgbClr val="0E1117"/>
@@ -8079,6 +7935,11 @@
                     </a:solidFill>
                   </a:tcPr>
                 </a:tc>
+                <a:extLst>
+                  <a:ext uri="{0D108BD9-81ED-4DB2-BD59-A6C34878D82A}">
+                    <a16:rowId xmlns:a16="http://schemas.microsoft.com/office/drawing/2014/main" val="10002"/>
+                  </a:ext>
+                </a:extLst>
               </a:tr>
               <a:tr h="457200">
                 <a:tc>
@@ -8086,7 +7947,7 @@
                     <a:bodyPr/>
                     <a:lstStyle/>
                     <a:p>
-                      <a:pPr indent="0" marL="0">
+                      <a:pPr marL="0" indent="0">
                         <a:buNone/>
                       </a:pPr>
                       <a:r>
@@ -8107,7 +7968,7 @@
                       </a:endParaRPr>
                     </a:p>
                   </a:txBody>
-                  <a:tcPr marL="91440" marR="91440" marT="45720" marB="45720" anchor="ctr">
+                  <a:tcPr anchor="ctr">
                     <a:lnL w="12700" cap="flat" cmpd="sng" algn="ctr">
                       <a:solidFill>
                         <a:srgbClr val="0E1117"/>
@@ -8154,7 +8015,7 @@
                     <a:bodyPr/>
                     <a:lstStyle/>
                     <a:p>
-                      <a:pPr indent="0" marL="0">
+                      <a:pPr marL="0" indent="0">
                         <a:buNone/>
                       </a:pPr>
                       <a:r>
@@ -8175,7 +8036,7 @@
                       </a:endParaRPr>
                     </a:p>
                   </a:txBody>
-                  <a:tcPr marL="91440" marR="91440" marT="45720" marB="45720" anchor="ctr">
+                  <a:tcPr anchor="ctr">
                     <a:lnL w="12700" cap="flat" cmpd="sng" algn="ctr">
                       <a:solidFill>
                         <a:srgbClr val="0E1117"/>
@@ -8217,6 +8078,11 @@
                     </a:solidFill>
                   </a:tcPr>
                 </a:tc>
+                <a:extLst>
+                  <a:ext uri="{0D108BD9-81ED-4DB2-BD59-A6C34878D82A}">
+                    <a16:rowId xmlns:a16="http://schemas.microsoft.com/office/drawing/2014/main" val="10003"/>
+                  </a:ext>
+                </a:extLst>
               </a:tr>
               <a:tr h="457200">
                 <a:tc>
@@ -8224,7 +8090,7 @@
                     <a:bodyPr/>
                     <a:lstStyle/>
                     <a:p>
-                      <a:pPr indent="0" marL="0">
+                      <a:pPr marL="0" indent="0">
                         <a:buNone/>
                       </a:pPr>
                       <a:r>
@@ -8245,7 +8111,7 @@
                       </a:endParaRPr>
                     </a:p>
                   </a:txBody>
-                  <a:tcPr marL="91440" marR="91440" marT="45720" marB="45720" anchor="ctr">
+                  <a:tcPr anchor="ctr">
                     <a:lnL w="12700" cap="flat" cmpd="sng" algn="ctr">
                       <a:solidFill>
                         <a:srgbClr val="0E1117"/>
@@ -8292,7 +8158,7 @@
                     <a:bodyPr/>
                     <a:lstStyle/>
                     <a:p>
-                      <a:pPr indent="0" marL="0">
+                      <a:pPr marL="0" indent="0">
                         <a:buNone/>
                       </a:pPr>
                       <a:r>
@@ -8313,7 +8179,7 @@
                       </a:endParaRPr>
                     </a:p>
                   </a:txBody>
-                  <a:tcPr marL="91440" marR="91440" marT="45720" marB="45720" anchor="ctr">
+                  <a:tcPr anchor="ctr">
                     <a:lnL w="12700" cap="flat" cmpd="sng" algn="ctr">
                       <a:solidFill>
                         <a:srgbClr val="0E1117"/>
@@ -8355,6 +8221,11 @@
                     </a:solidFill>
                   </a:tcPr>
                 </a:tc>
+                <a:extLst>
+                  <a:ext uri="{0D108BD9-81ED-4DB2-BD59-A6C34878D82A}">
+                    <a16:rowId xmlns:a16="http://schemas.microsoft.com/office/drawing/2014/main" val="10004"/>
+                  </a:ext>
+                </a:extLst>
               </a:tr>
               <a:tr h="457200">
                 <a:tc>
@@ -8362,7 +8233,7 @@
                     <a:bodyPr/>
                     <a:lstStyle/>
                     <a:p>
-                      <a:pPr indent="0" marL="0">
+                      <a:pPr marL="0" indent="0">
                         <a:buNone/>
                       </a:pPr>
                       <a:r>
@@ -8383,7 +8254,7 @@
                       </a:endParaRPr>
                     </a:p>
                   </a:txBody>
-                  <a:tcPr marL="91440" marR="91440" marT="45720" marB="45720" anchor="ctr">
+                  <a:tcPr anchor="ctr">
                     <a:lnL w="12700" cap="flat" cmpd="sng" algn="ctr">
                       <a:solidFill>
                         <a:srgbClr val="0E1117"/>
@@ -8430,7 +8301,7 @@
                     <a:bodyPr/>
                     <a:lstStyle/>
                     <a:p>
-                      <a:pPr indent="0" marL="0">
+                      <a:pPr marL="0" indent="0">
                         <a:buNone/>
                       </a:pPr>
                       <a:r>
@@ -8451,7 +8322,7 @@
                       </a:endParaRPr>
                     </a:p>
                   </a:txBody>
-                  <a:tcPr marL="91440" marR="91440" marT="45720" marB="45720" anchor="ctr">
+                  <a:tcPr anchor="ctr">
                     <a:lnL w="12700" cap="flat" cmpd="sng" algn="ctr">
                       <a:solidFill>
                         <a:srgbClr val="0E1117"/>
@@ -8493,6 +8364,11 @@
                     </a:solidFill>
                   </a:tcPr>
                 </a:tc>
+                <a:extLst>
+                  <a:ext uri="{0D108BD9-81ED-4DB2-BD59-A6C34878D82A}">
+                    <a16:rowId xmlns:a16="http://schemas.microsoft.com/office/drawing/2014/main" val="10005"/>
+                  </a:ext>
+                </a:extLst>
               </a:tr>
               <a:tr h="457200">
                 <a:tc>
@@ -8500,7 +8376,7 @@
                     <a:bodyPr/>
                     <a:lstStyle/>
                     <a:p>
-                      <a:pPr indent="0" marL="0">
+                      <a:pPr marL="0" indent="0">
                         <a:buNone/>
                       </a:pPr>
                       <a:r>
@@ -8521,7 +8397,7 @@
                       </a:endParaRPr>
                     </a:p>
                   </a:txBody>
-                  <a:tcPr marL="91440" marR="91440" marT="45720" marB="45720" anchor="ctr">
+                  <a:tcPr anchor="ctr">
                     <a:lnL w="12700" cap="flat" cmpd="sng" algn="ctr">
                       <a:solidFill>
                         <a:srgbClr val="0E1117"/>
@@ -8568,7 +8444,7 @@
                     <a:bodyPr/>
                     <a:lstStyle/>
                     <a:p>
-                      <a:pPr indent="0" marL="0">
+                      <a:pPr marL="0" indent="0">
                         <a:buNone/>
                       </a:pPr>
                       <a:r>
@@ -8589,7 +8465,7 @@
                       </a:endParaRPr>
                     </a:p>
                   </a:txBody>
-                  <a:tcPr marL="91440" marR="91440" marT="45720" marB="45720" anchor="ctr">
+                  <a:tcPr anchor="ctr">
                     <a:lnL w="12700" cap="flat" cmpd="sng" algn="ctr">
                       <a:solidFill>
                         <a:srgbClr val="0E1117"/>
@@ -8631,6 +8507,11 @@
                     </a:solidFill>
                   </a:tcPr>
                 </a:tc>
+                <a:extLst>
+                  <a:ext uri="{0D108BD9-81ED-4DB2-BD59-A6C34878D82A}">
+                    <a16:rowId xmlns:a16="http://schemas.microsoft.com/office/drawing/2014/main" val="10006"/>
+                  </a:ext>
+                </a:extLst>
               </a:tr>
             </a:tbl>
           </a:graphicData>
@@ -8937,4 +8818,299 @@
     </a:ext>
   </a:extLst>
 </a:theme>
+</file>
+
+<file path=ppt/theme/theme2.xml><?xml version="1.0" encoding="utf-8"?>
+<a:theme xmlns:a="http://schemas.openxmlformats.org/drawingml/2006/main" name="Office Theme">
+  <a:themeElements>
+    <a:clrScheme name="Office">
+      <a:dk1>
+        <a:sysClr val="windowText" lastClr="000000"/>
+      </a:dk1>
+      <a:lt1>
+        <a:sysClr val="window" lastClr="FFFFFF"/>
+      </a:lt1>
+      <a:dk2>
+        <a:srgbClr val="44546A"/>
+      </a:dk2>
+      <a:lt2>
+        <a:srgbClr val="E7E6E6"/>
+      </a:lt2>
+      <a:accent1>
+        <a:srgbClr val="4472C4"/>
+      </a:accent1>
+      <a:accent2>
+        <a:srgbClr val="ED7D31"/>
+      </a:accent2>
+      <a:accent3>
+        <a:srgbClr val="A5A5A5"/>
+      </a:accent3>
+      <a:accent4>
+        <a:srgbClr val="FFC000"/>
+      </a:accent4>
+      <a:accent5>
+        <a:srgbClr val="5B9BD5"/>
+      </a:accent5>
+      <a:accent6>
+        <a:srgbClr val="70AD47"/>
+      </a:accent6>
+      <a:hlink>
+        <a:srgbClr val="0563C1"/>
+      </a:hlink>
+      <a:folHlink>
+        <a:srgbClr val="954F72"/>
+      </a:folHlink>
+    </a:clrScheme>
+    <a:fontScheme name="Office">
+      <a:majorFont>
+        <a:latin typeface="Calibri Light" panose="020F0302020204030204"/>
+        <a:ea typeface=""/>
+        <a:cs typeface=""/>
+        <a:font script="Jpan" typeface="游ゴシック Light"/>
+        <a:font script="Hang" typeface="맑은 고딕"/>
+        <a:font script="Hans" typeface="等线 Light"/>
+        <a:font script="Hant" typeface="新細明體"/>
+        <a:font script="Arab" typeface="Times New Roman"/>
+        <a:font script="Hebr" typeface="Times New Roman"/>
+        <a:font script="Thai" typeface="Angsana New"/>
+        <a:font script="Ethi" typeface="Nyala"/>
+        <a:font script="Beng" typeface="Vrinda"/>
+        <a:font script="Gujr" typeface="Shruti"/>
+        <a:font script="Khmr" typeface="MoolBoran"/>
+        <a:font script="Knda" typeface="Tunga"/>
+        <a:font script="Guru" typeface="Raavi"/>
+        <a:font script="Cans" typeface="Euphemia"/>
+        <a:font script="Cher" typeface="Plantagenet Cherokee"/>
+        <a:font script="Yiii" typeface="Microsoft Yi Baiti"/>
+        <a:font script="Tibt" typeface="Microsoft Himalaya"/>
+        <a:font script="Thaa" typeface="MV Boli"/>
+        <a:font script="Deva" typeface="Mangal"/>
+        <a:font script="Telu" typeface="Gautami"/>
+        <a:font script="Taml" typeface="Latha"/>
+        <a:font script="Syrc" typeface="Estrangelo Edessa"/>
+        <a:font script="Orya" typeface="Kalinga"/>
+        <a:font script="Mlym" typeface="Kartika"/>
+        <a:font script="Laoo" typeface="DokChampa"/>
+        <a:font script="Sinh" typeface="Iskoola Pota"/>
+        <a:font script="Mong" typeface="Mongolian Baiti"/>
+        <a:font script="Viet" typeface="Times New Roman"/>
+        <a:font script="Uigh" typeface="Microsoft Uighur"/>
+        <a:font script="Geor" typeface="Sylfaen"/>
+        <a:font script="Armn" typeface="Arial"/>
+        <a:font script="Bugi" typeface="Leelawadee UI"/>
+        <a:font script="Bopo" typeface="Microsoft JhengHei"/>
+        <a:font script="Java" typeface="Javanese Text"/>
+        <a:font script="Lisu" typeface="Segoe UI"/>
+        <a:font script="Mymr" typeface="Myanmar Text"/>
+        <a:font script="Nkoo" typeface="Ebrima"/>
+        <a:font script="Olck" typeface="Nirmala UI"/>
+        <a:font script="Osma" typeface="Ebrima"/>
+        <a:font script="Phag" typeface="Phagspa"/>
+        <a:font script="Syrn" typeface="Estrangelo Edessa"/>
+        <a:font script="Syrj" typeface="Estrangelo Edessa"/>
+        <a:font script="Syre" typeface="Estrangelo Edessa"/>
+        <a:font script="Sora" typeface="Nirmala UI"/>
+        <a:font script="Tale" typeface="Microsoft Tai Le"/>
+        <a:font script="Talu" typeface="Microsoft New Tai Lue"/>
+        <a:font script="Tfng" typeface="Ebrima"/>
+      </a:majorFont>
+      <a:minorFont>
+        <a:latin typeface="Calibri" panose="020F0502020204030204"/>
+        <a:ea typeface=""/>
+        <a:cs typeface=""/>
+        <a:font script="Jpan" typeface="游ゴシック"/>
+        <a:font script="Hang" typeface="맑은 고딕"/>
+        <a:font script="Hans" typeface="等线"/>
+        <a:font script="Hant" typeface="新細明體"/>
+        <a:font script="Arab" typeface="Arial"/>
+        <a:font script="Hebr" typeface="Arial"/>
+        <a:font script="Thai" typeface="Cordia New"/>
+        <a:font script="Ethi" typeface="Nyala"/>
+        <a:font script="Beng" typeface="Vrinda"/>
+        <a:font script="Gujr" typeface="Shruti"/>
+        <a:font script="Khmr" typeface="DaunPenh"/>
+        <a:font script="Knda" typeface="Tunga"/>
+        <a:font script="Guru" typeface="Raavi"/>
+        <a:font script="Cans" typeface="Euphemia"/>
+        <a:font script="Cher" typeface="Plantagenet Cherokee"/>
+        <a:font script="Yiii" typeface="Microsoft Yi Baiti"/>
+        <a:font script="Tibt" typeface="Microsoft Himalaya"/>
+        <a:font script="Thaa" typeface="MV Boli"/>
+        <a:font script="Deva" typeface="Mangal"/>
+        <a:font script="Telu" typeface="Gautami"/>
+        <a:font script="Taml" typeface="Latha"/>
+        <a:font script="Syrc" typeface="Estrangelo Edessa"/>
+        <a:font script="Orya" typeface="Kalinga"/>
+        <a:font script="Mlym" typeface="Kartika"/>
+        <a:font script="Laoo" typeface="DokChampa"/>
+        <a:font script="Sinh" typeface="Iskoola Pota"/>
+        <a:font script="Mong" typeface="Mongolian Baiti"/>
+        <a:font script="Viet" typeface="Arial"/>
+        <a:font script="Uigh" typeface="Microsoft Uighur"/>
+        <a:font script="Geor" typeface="Sylfaen"/>
+        <a:font script="Armn" typeface="Arial"/>
+        <a:font script="Bugi" typeface="Leelawadee UI"/>
+        <a:font script="Bopo" typeface="Microsoft JhengHei"/>
+        <a:font script="Java" typeface="Javanese Text"/>
+        <a:font script="Lisu" typeface="Segoe UI"/>
+        <a:font script="Mymr" typeface="Myanmar Text"/>
+        <a:font script="Nkoo" typeface="Ebrima"/>
+        <a:font script="Olck" typeface="Nirmala UI"/>
+        <a:font script="Osma" typeface="Ebrima"/>
+        <a:font script="Phag" typeface="Phagspa"/>
+        <a:font script="Syrn" typeface="Estrangelo Edessa"/>
+        <a:font script="Syrj" typeface="Estrangelo Edessa"/>
+        <a:font script="Syre" typeface="Estrangelo Edessa"/>
+        <a:font script="Sora" typeface="Nirmala UI"/>
+        <a:font script="Tale" typeface="Microsoft Tai Le"/>
+        <a:font script="Talu" typeface="Microsoft New Tai Lue"/>
+        <a:font script="Tfng" typeface="Ebrima"/>
+      </a:minorFont>
+    </a:fontScheme>
+    <a:fmtScheme name="Office">
+      <a:fillStyleLst>
+        <a:solidFill>
+          <a:schemeClr val="phClr"/>
+        </a:solidFill>
+        <a:gradFill rotWithShape="1">
+          <a:gsLst>
+            <a:gs pos="0">
+              <a:schemeClr val="phClr">
+                <a:lumMod val="110000"/>
+                <a:satMod val="105000"/>
+                <a:tint val="67000"/>
+              </a:schemeClr>
+            </a:gs>
+            <a:gs pos="50000">
+              <a:schemeClr val="phClr">
+                <a:lumMod val="105000"/>
+                <a:satMod val="103000"/>
+                <a:tint val="73000"/>
+              </a:schemeClr>
+            </a:gs>
+            <a:gs pos="100000">
+              <a:schemeClr val="phClr">
+                <a:lumMod val="105000"/>
+                <a:satMod val="109000"/>
+                <a:tint val="81000"/>
+              </a:schemeClr>
+            </a:gs>
+          </a:gsLst>
+          <a:lin ang="5400000" scaled="0"/>
+        </a:gradFill>
+        <a:gradFill rotWithShape="1">
+          <a:gsLst>
+            <a:gs pos="0">
+              <a:schemeClr val="phClr">
+                <a:satMod val="103000"/>
+                <a:lumMod val="102000"/>
+                <a:tint val="94000"/>
+              </a:schemeClr>
+            </a:gs>
+            <a:gs pos="50000">
+              <a:schemeClr val="phClr">
+                <a:satMod val="110000"/>
+                <a:lumMod val="100000"/>
+                <a:shade val="100000"/>
+              </a:schemeClr>
+            </a:gs>
+            <a:gs pos="100000">
+              <a:schemeClr val="phClr">
+                <a:lumMod val="99000"/>
+                <a:satMod val="120000"/>
+                <a:shade val="78000"/>
+              </a:schemeClr>
+            </a:gs>
+          </a:gsLst>
+          <a:lin ang="5400000" scaled="0"/>
+        </a:gradFill>
+      </a:fillStyleLst>
+      <a:lnStyleLst>
+        <a:ln w="6350" cap="flat" cmpd="sng" algn="ctr">
+          <a:solidFill>
+            <a:schemeClr val="phClr"/>
+          </a:solidFill>
+          <a:prstDash val="solid"/>
+          <a:miter lim="800000"/>
+        </a:ln>
+        <a:ln w="12700" cap="flat" cmpd="sng" algn="ctr">
+          <a:solidFill>
+            <a:schemeClr val="phClr"/>
+          </a:solidFill>
+          <a:prstDash val="solid"/>
+          <a:miter lim="800000"/>
+        </a:ln>
+        <a:ln w="19050" cap="flat" cmpd="sng" algn="ctr">
+          <a:solidFill>
+            <a:schemeClr val="phClr"/>
+          </a:solidFill>
+          <a:prstDash val="solid"/>
+          <a:miter lim="800000"/>
+        </a:ln>
+      </a:lnStyleLst>
+      <a:effectStyleLst>
+        <a:effectStyle>
+          <a:effectLst/>
+        </a:effectStyle>
+        <a:effectStyle>
+          <a:effectLst/>
+        </a:effectStyle>
+        <a:effectStyle>
+          <a:effectLst>
+            <a:outerShdw blurRad="57150" dist="19050" dir="5400000" algn="ctr" rotWithShape="0">
+              <a:srgbClr val="000000">
+                <a:alpha val="63000"/>
+              </a:srgbClr>
+            </a:outerShdw>
+          </a:effectLst>
+        </a:effectStyle>
+      </a:effectStyleLst>
+      <a:bgFillStyleLst>
+        <a:solidFill>
+          <a:schemeClr val="phClr"/>
+        </a:solidFill>
+        <a:solidFill>
+          <a:schemeClr val="phClr">
+            <a:tint val="95000"/>
+            <a:satMod val="170000"/>
+          </a:schemeClr>
+        </a:solidFill>
+        <a:gradFill rotWithShape="1">
+          <a:gsLst>
+            <a:gs pos="0">
+              <a:schemeClr val="phClr">
+                <a:tint val="93000"/>
+                <a:satMod val="150000"/>
+                <a:shade val="98000"/>
+                <a:lumMod val="102000"/>
+              </a:schemeClr>
+            </a:gs>
+            <a:gs pos="50000">
+              <a:schemeClr val="phClr">
+                <a:tint val="98000"/>
+                <a:satMod val="130000"/>
+                <a:shade val="90000"/>
+                <a:lumMod val="103000"/>
+              </a:schemeClr>
+            </a:gs>
+            <a:gs pos="100000">
+              <a:schemeClr val="phClr">
+                <a:shade val="63000"/>
+                <a:satMod val="120000"/>
+              </a:schemeClr>
+            </a:gs>
+          </a:gsLst>
+          <a:lin ang="5400000" scaled="0"/>
+        </a:gradFill>
+      </a:bgFillStyleLst>
+    </a:fmtScheme>
+  </a:themeElements>
+  <a:objectDefaults/>
+  <a:extraClrSchemeLst/>
+  <a:extLst>
+    <a:ext uri="{05A4C25C-085E-4340-85A3-A5531E510DB2}">
+      <thm15:themeFamily xmlns:thm15="http://schemas.microsoft.com/office/thememl/2012/main" name="Office Theme" id="{62F939B6-93AF-4DB8-9C6B-D6C7DFDC589F}" vid="{4A3C46E8-61CC-4603-A589-7422A47A8E4A}"/>
+    </a:ext>
+  </a:extLst>
+</a:theme>
 </file>
</xml_diff>

<commit_message>
Day 89: Wrap-aware hue fix, tests, and depth prep
</commit_message>
<xml_diff>
--- a/docs/presentation.pptx
+++ b/docs/presentation.pptx
@@ -384,8 +384,12 @@
               <a:t>Testing has three levels. </a:t>
             </a:r>
             <a:r>
+              <a:rPr lang="en-IN"/>
+              <a:t>Fourteen </a:t>
+            </a:r>
+            <a:r>
               <a:rPr lang="en-IN" dirty="0"/>
-              <a:t>Twelve automated </a:t>
+              <a:t>automated </a:t>
             </a:r>
             <a:r>
               <a:rPr lang="en-IN" dirty="0" err="1"/>
@@ -2541,7 +2545,7 @@
                 <a:ea typeface="Cambria" pitchFamily="34" charset="-122"/>
                 <a:cs typeface="Cambria" pitchFamily="34" charset="-120"/>
               </a:rPr>
-              <a:t>12</a:t>
+              <a:t>14</a:t>
             </a:r>
             <a:endParaRPr lang="en-US" sz="6000" dirty="0"/>
           </a:p>

</xml_diff>